<commit_message>
Update slides for MHW case study.
</commit_message>
<xml_diff>
--- a/lectures/Day10_Programming_case_studies.pptx
+++ b/lectures/Day10_Programming_case_studies.pptx
@@ -291,7 +291,7 @@
           <a:p>
             <a:fld id="{1CDF4D61-2834-5446-B4D5-4011A20EA5BA}" type="datetimeFigureOut">
               <a:rPr lang="en-GB" smtClean="0"/>
-              <a:t>22/06/2026</a:t>
+              <a:t>23/06/2026</a:t>
             </a:fld>
             <a:endParaRPr lang="en-GB"/>
           </a:p>
@@ -491,7 +491,7 @@
           <a:p>
             <a:fld id="{1CDF4D61-2834-5446-B4D5-4011A20EA5BA}" type="datetimeFigureOut">
               <a:rPr lang="en-GB" smtClean="0"/>
-              <a:t>22/06/2026</a:t>
+              <a:t>23/06/2026</a:t>
             </a:fld>
             <a:endParaRPr lang="en-GB"/>
           </a:p>
@@ -701,7 +701,7 @@
           <a:p>
             <a:fld id="{1CDF4D61-2834-5446-B4D5-4011A20EA5BA}" type="datetimeFigureOut">
               <a:rPr lang="en-GB" smtClean="0"/>
-              <a:t>22/06/2026</a:t>
+              <a:t>23/06/2026</a:t>
             </a:fld>
             <a:endParaRPr lang="en-GB"/>
           </a:p>
@@ -901,7 +901,7 @@
           <a:p>
             <a:fld id="{1CDF4D61-2834-5446-B4D5-4011A20EA5BA}" type="datetimeFigureOut">
               <a:rPr lang="en-GB" smtClean="0"/>
-              <a:t>22/06/2026</a:t>
+              <a:t>23/06/2026</a:t>
             </a:fld>
             <a:endParaRPr lang="en-GB"/>
           </a:p>
@@ -1177,7 +1177,7 @@
           <a:p>
             <a:fld id="{1CDF4D61-2834-5446-B4D5-4011A20EA5BA}" type="datetimeFigureOut">
               <a:rPr lang="en-GB" smtClean="0"/>
-              <a:t>22/06/2026</a:t>
+              <a:t>23/06/2026</a:t>
             </a:fld>
             <a:endParaRPr lang="en-GB"/>
           </a:p>
@@ -1445,7 +1445,7 @@
           <a:p>
             <a:fld id="{1CDF4D61-2834-5446-B4D5-4011A20EA5BA}" type="datetimeFigureOut">
               <a:rPr lang="en-GB" smtClean="0"/>
-              <a:t>22/06/2026</a:t>
+              <a:t>23/06/2026</a:t>
             </a:fld>
             <a:endParaRPr lang="en-GB"/>
           </a:p>
@@ -1860,7 +1860,7 @@
           <a:p>
             <a:fld id="{1CDF4D61-2834-5446-B4D5-4011A20EA5BA}" type="datetimeFigureOut">
               <a:rPr lang="en-GB" smtClean="0"/>
-              <a:t>22/06/2026</a:t>
+              <a:t>23/06/2026</a:t>
             </a:fld>
             <a:endParaRPr lang="en-GB"/>
           </a:p>
@@ -2002,7 +2002,7 @@
           <a:p>
             <a:fld id="{1CDF4D61-2834-5446-B4D5-4011A20EA5BA}" type="datetimeFigureOut">
               <a:rPr lang="en-GB" smtClean="0"/>
-              <a:t>22/06/2026</a:t>
+              <a:t>23/06/2026</a:t>
             </a:fld>
             <a:endParaRPr lang="en-GB"/>
           </a:p>
@@ -2115,7 +2115,7 @@
           <a:p>
             <a:fld id="{1CDF4D61-2834-5446-B4D5-4011A20EA5BA}" type="datetimeFigureOut">
               <a:rPr lang="en-GB" smtClean="0"/>
-              <a:t>22/06/2026</a:t>
+              <a:t>23/06/2026</a:t>
             </a:fld>
             <a:endParaRPr lang="en-GB"/>
           </a:p>
@@ -2428,7 +2428,7 @@
           <a:p>
             <a:fld id="{1CDF4D61-2834-5446-B4D5-4011A20EA5BA}" type="datetimeFigureOut">
               <a:rPr lang="en-GB" smtClean="0"/>
-              <a:t>22/06/2026</a:t>
+              <a:t>23/06/2026</a:t>
             </a:fld>
             <a:endParaRPr lang="en-GB"/>
           </a:p>
@@ -2717,7 +2717,7 @@
           <a:p>
             <a:fld id="{1CDF4D61-2834-5446-B4D5-4011A20EA5BA}" type="datetimeFigureOut">
               <a:rPr lang="en-GB" smtClean="0"/>
-              <a:t>22/06/2026</a:t>
+              <a:t>23/06/2026</a:t>
             </a:fld>
             <a:endParaRPr lang="en-GB"/>
           </a:p>
@@ -2960,7 +2960,7 @@
           <a:p>
             <a:fld id="{1CDF4D61-2834-5446-B4D5-4011A20EA5BA}" type="datetimeFigureOut">
               <a:rPr lang="en-GB" smtClean="0"/>
-              <a:t>22/06/2026</a:t>
+              <a:t>23/06/2026</a:t>
             </a:fld>
             <a:endParaRPr lang="en-GB"/>
           </a:p>
@@ -5040,8 +5040,13 @@
           <a:p>
             <a:r>
               <a:rPr lang="en-GB" dirty="0"/>
-              <a:t>Influence on biota?</a:t>
-            </a:r>
+              <a:t>Influence on </a:t>
+            </a:r>
+            <a:r>
+              <a:rPr lang="en-GB"/>
+              <a:t>fish community</a:t>
+            </a:r>
+            <a:endParaRPr lang="en-GB" dirty="0"/>
           </a:p>
           <a:p>
             <a:r>

</xml_diff>